<commit_message>
Add Microsoft IQ playground and industry scenarios
Add the interactive Microsoft IQ Playground, Pages deployment workflow, synchronized workshop documentation, and a detailed industry scenario design guide with operational contracts, safety gates, fallback behavior, and PoC-to-production guidance.\n\nCo-authored-by: Copilot <223556219+Copilot@users.noreply.github.com>
</commit_message>
<xml_diff>
--- a/common/docs/Microsoft_IQ_Workshop_Full_Architecture.pptx
+++ b/common/docs/Microsoft_IQ_Workshop_Full_Architecture.pptx
@@ -4134,7 +4134,7 @@
                 </a:solidFill>
                 <a:latin typeface="Aptos"/>
               </a:rPr>
-              <a:t>Source: Microsoft_IQ_Workshop_Integrated_Plan_v3.0.md</a:t>
+              <a:t>Source: Microsoft_IQ_Workshop_Integrated_Plan.md</a:t>
             </a:r>
           </a:p>
         </p:txBody>
@@ -7101,7 +7101,7 @@
                 </a:solidFill>
                 <a:latin typeface="Aptos"/>
               </a:rPr>
-              <a:t>네 구성요소 Microsoft IQ 아키텍처</a:t>
+              <a:t>Microsoft IQ 아키텍처</a:t>
             </a:r>
           </a:p>
         </p:txBody>
@@ -12610,7 +12610,7 @@
                 </a:solidFill>
                 <a:latin typeface="Aptos"/>
               </a:rPr>
-              <a:t>WEBIQ_HANDOFF_PACKAGE</a:t>
+              <a:t>TRACK4_FOUNDRYIQ_HANDOFF_PACKAGE</a:t>
             </a:r>
           </a:p>
         </p:txBody>

</xml_diff>